<commit_message>
Correct buyer checkout claim in submission slides
</commit_message>
<xml_diff>
--- a/assets/deck/pengwin-agent-arena-submission.pptx
+++ b/assets/deck/pengwin-agent-arena-submission.pptx
@@ -2,17 +2,17 @@
 <file path=ppt/presentation.xml><?xml version="1.0" encoding="utf-8"?>
 <p:presentation xmlns:p="http://schemas.openxmlformats.org/presentationml/2006/main">
   <p:sldMasterIdLst>
-    <p:sldMasterId xmlns:r="http://schemas.openxmlformats.org/officeDocument/2006/relationships" id="2147483648" r:id="Re4787e31fe384ee6"/>
+    <p:sldMasterId xmlns:r="http://schemas.openxmlformats.org/officeDocument/2006/relationships" id="2147483648" r:id="R6214d1d72cdc4db9"/>
   </p:sldMasterIdLst>
   <p:notesMasterIdLst>
-    <p:notesMasterId xmlns:r="http://schemas.openxmlformats.org/officeDocument/2006/relationships" r:id="Rbad613dfddd04117"/>
+    <p:notesMasterId xmlns:r="http://schemas.openxmlformats.org/officeDocument/2006/relationships" r:id="Re57161d2596740a1"/>
   </p:notesMasterIdLst>
   <p:sldIdLst>
-    <p:sldId xmlns:r="http://schemas.openxmlformats.org/officeDocument/2006/relationships" id="256" r:id="R13b7aba87b2243de"/>
-    <p:sldId xmlns:r="http://schemas.openxmlformats.org/officeDocument/2006/relationships" id="257" r:id="Rbc943389423b4604"/>
-    <p:sldId xmlns:r="http://schemas.openxmlformats.org/officeDocument/2006/relationships" id="258" r:id="R03b4f3f6ca9a4d1d"/>
-    <p:sldId xmlns:r="http://schemas.openxmlformats.org/officeDocument/2006/relationships" id="259" r:id="R95da82365bd24b32"/>
-    <p:sldId xmlns:r="http://schemas.openxmlformats.org/officeDocument/2006/relationships" id="260" r:id="R60fb581d0d8a4e44"/>
+    <p:sldId xmlns:r="http://schemas.openxmlformats.org/officeDocument/2006/relationships" id="256" r:id="R27e020ad42584af9"/>
+    <p:sldId xmlns:r="http://schemas.openxmlformats.org/officeDocument/2006/relationships" id="257" r:id="R29c4ba5718dc4a2f"/>
+    <p:sldId xmlns:r="http://schemas.openxmlformats.org/officeDocument/2006/relationships" id="258" r:id="Ra72ac14c85f241df"/>
+    <p:sldId xmlns:r="http://schemas.openxmlformats.org/officeDocument/2006/relationships" id="259" r:id="Reca9889c44ac428a"/>
+    <p:sldId xmlns:r="http://schemas.openxmlformats.org/officeDocument/2006/relationships" id="260" r:id="Rb286375701fa4723"/>
   </p:sldIdLst>
   <p:sldSz cx="12192000" cy="6858000"/>
   <p:notesSz cx="6858000" cy="9144000"/>
@@ -521,7 +521,7 @@
           <a:lstStyle xmlns:a="http://schemas.openxmlformats.org/drawingml/2006/main"/>
           <a:p xmlns:a="http://schemas.openxmlformats.org/drawingml/2006/main">
             <a:r>
-              <a:t>September 27 receipts from the root implementation agent: a real Vultr inference test proposed a typed Salesforce Park project for about a month away, 30 bottles and local AI founders. Missing time, capacity, artwork and delivery destination remain explicit. At 07:53 UTC a live automated bot-labelled Slack project sourced 30 bottles at a product-only estimate of $607.50–$702.30; after worker restart, a same-thread 07:58 UTC amendment changed to 24 bottles at $486.00–$561.84, with the same project ID. All four role jobs completed both times. No checkout, payment, booking or invitation send.</a:t>
+              <a:t>September 27 receipts from the root implementation agent: a real Vultr inference test proposed a typed Salesforce Park project for about a month away, 30 bottles and local AI founders. Missing time, capacity, artwork and delivery destination remain explicit. At 07:53 UTC a live automated bot-labelled Slack project sourced 30 bottles at a product-only estimate of $607.50–$702.30; after worker restart, a same-thread 07:58 UTC amendment changed to 24 bottles at $486.00–$561.84, with the same project ID. All four role jobs completed both times. Buyer checkout_status is NOT_READY because a store token, artwork, chosen variant, shipping and tax are missing. No checkout, payment, booking or invitation send.</a:t>
             </a:r>
           </a:p>
         </p:txBody>
@@ -814,7 +814,7 @@
   </p:cSld>
   <p:clrMap bg1="lt1" tx1="dk1" bg2="lt2" tx2="dk2" accent1="accent1" accent2="accent2" accent3="accent3" accent4="accent4" accent5="accent5" accent6="accent6" hlink="hlink" folHlink="folHlink"/>
   <p:sldLayoutIdLst>
-    <p:sldLayoutId xmlns:r="http://schemas.openxmlformats.org/officeDocument/2006/relationships" id="2147483649" r:id="R39e73c907a0c4fd5"/>
+    <p:sldLayoutId xmlns:r="http://schemas.openxmlformats.org/officeDocument/2006/relationships" id="2147483649" r:id="R8e9be837b13f43e2"/>
   </p:sldLayoutIdLst>
   <p:txStyles>
     <p:titleStyle>
@@ -1365,7 +1365,7 @@
           <p:cNvPr id="5" name="">
             <a:extLst xmlns:a="http://schemas.openxmlformats.org/drawingml/2006/main">
               <a:ext uri="{FF2B5EF4-FFF2-40B4-BE49-F238E27FC236}">
-                <a16:creationId xmlns:a16="http://schemas.microsoft.com/office/drawing/2014/main" id="{BEE514DD-7E9B-4A0D-A46F-F38EC255D4E2}"/>
+                <a16:creationId xmlns:a16="http://schemas.microsoft.com/office/drawing/2014/main" id="{C85A6A1F-0148-413D-8D1C-97C68F45A5A8}"/>
               </a:ext>
             </a:extLst>
           </p:cNvPr>
@@ -1422,7 +1422,7 @@
           <p:cNvPr id="2" name="">
             <a:extLst xmlns:a="http://schemas.openxmlformats.org/drawingml/2006/main">
               <a:ext uri="{FF2B5EF4-FFF2-40B4-BE49-F238E27FC236}">
-                <a16:creationId xmlns:a16="http://schemas.microsoft.com/office/drawing/2014/main" id="{FABC072A-6217-4DBE-B102-4AA00FE9FF27}"/>
+                <a16:creationId xmlns:a16="http://schemas.microsoft.com/office/drawing/2014/main" id="{1F042C14-EC64-43B9-BA08-D844C7E874DB}"/>
               </a:ext>
             </a:extLst>
           </p:cNvPr>
@@ -1479,7 +1479,7 @@
           <p:cNvPr id="3" name="">
             <a:extLst xmlns:a="http://schemas.openxmlformats.org/drawingml/2006/main">
               <a:ext uri="{FF2B5EF4-FFF2-40B4-BE49-F238E27FC236}">
-                <a16:creationId xmlns:a16="http://schemas.microsoft.com/office/drawing/2014/main" id="{DE2D2936-154F-4496-96B7-E0015D4F400A}"/>
+                <a16:creationId xmlns:a16="http://schemas.microsoft.com/office/drawing/2014/main" id="{DA63401C-B149-47BC-BA82-48ED829DEDA3}"/>
               </a:ext>
             </a:extLst>
           </p:cNvPr>
@@ -1536,7 +1536,7 @@
           <p:cNvPr id="4" name="">
             <a:extLst xmlns:a="http://schemas.openxmlformats.org/drawingml/2006/main">
               <a:ext uri="{FF2B5EF4-FFF2-40B4-BE49-F238E27FC236}">
-                <a16:creationId xmlns:a16="http://schemas.microsoft.com/office/drawing/2014/main" id="{9B695586-846F-4053-9E99-A69C47F738BE}"/>
+                <a16:creationId xmlns:a16="http://schemas.microsoft.com/office/drawing/2014/main" id="{8D13D39B-42AF-4CF4-86E6-4F333E92AB75}"/>
               </a:ext>
             </a:extLst>
           </p:cNvPr>
@@ -1591,7 +1591,7 @@
     </p:spTree>
     <p:extLst>
       <p:ext uri="{BB962C8B-B14F-4D97-AF65-F5344CB8AC3E}">
-        <p14:creationId xmlns:p14="http://schemas.microsoft.com/office/powerpoint/2010/main" val="1815348704"/>
+        <p14:creationId xmlns:p14="http://schemas.microsoft.com/office/powerpoint/2010/main" val="1096281689"/>
       </p:ext>
     </p:extLst>
   </p:cSld>
@@ -1622,7 +1622,7 @@
           <p:cNvPr id="12" name="">
             <a:extLst xmlns:a="http://schemas.openxmlformats.org/drawingml/2006/main">
               <a:ext uri="{FF2B5EF4-FFF2-40B4-BE49-F238E27FC236}">
-                <a16:creationId xmlns:a16="http://schemas.microsoft.com/office/drawing/2014/main" id="{A52C65C0-7D3F-4DA1-ABA7-B3C12CA3861A}"/>
+                <a16:creationId xmlns:a16="http://schemas.microsoft.com/office/drawing/2014/main" id="{314C2881-8F58-4717-8F95-A5F10FC917EE}"/>
               </a:ext>
             </a:extLst>
           </p:cNvPr>
@@ -1679,7 +1679,7 @@
           <p:cNvPr id="2" name="">
             <a:extLst xmlns:a="http://schemas.openxmlformats.org/drawingml/2006/main">
               <a:ext uri="{FF2B5EF4-FFF2-40B4-BE49-F238E27FC236}">
-                <a16:creationId xmlns:a16="http://schemas.microsoft.com/office/drawing/2014/main" id="{CBD7E3DB-CA7E-4442-AFED-A47C92435F71}"/>
+                <a16:creationId xmlns:a16="http://schemas.microsoft.com/office/drawing/2014/main" id="{F4AF4BD4-2484-47AC-8066-2595179F1D81}"/>
               </a:ext>
             </a:extLst>
           </p:cNvPr>
@@ -1736,7 +1736,7 @@
           <p:cNvPr id="3" name="">
             <a:extLst xmlns:a="http://schemas.openxmlformats.org/drawingml/2006/main">
               <a:ext uri="{FF2B5EF4-FFF2-40B4-BE49-F238E27FC236}">
-                <a16:creationId xmlns:a16="http://schemas.microsoft.com/office/drawing/2014/main" id="{1B89EC38-4AB4-4254-BEE7-ACC2DC45F9D4}"/>
+                <a16:creationId xmlns:a16="http://schemas.microsoft.com/office/drawing/2014/main" id="{50E7E6FA-F2BA-48C6-972C-1E8801D05CFD}"/>
               </a:ext>
             </a:extLst>
           </p:cNvPr>
@@ -1793,7 +1793,7 @@
           <p:cNvPr id="4" name="">
             <a:extLst xmlns:a="http://schemas.openxmlformats.org/drawingml/2006/main">
               <a:ext uri="{FF2B5EF4-FFF2-40B4-BE49-F238E27FC236}">
-                <a16:creationId xmlns:a16="http://schemas.microsoft.com/office/drawing/2014/main" id="{DCD12675-39FA-43D4-8B36-C8169BAA7C18}"/>
+                <a16:creationId xmlns:a16="http://schemas.microsoft.com/office/drawing/2014/main" id="{0BDB0448-2D0E-4C60-B36F-9EA88B094968}"/>
               </a:ext>
             </a:extLst>
           </p:cNvPr>
@@ -1850,7 +1850,7 @@
           <p:cNvPr id="5" name="">
             <a:extLst xmlns:a="http://schemas.openxmlformats.org/drawingml/2006/main">
               <a:ext uri="{FF2B5EF4-FFF2-40B4-BE49-F238E27FC236}">
-                <a16:creationId xmlns:a16="http://schemas.microsoft.com/office/drawing/2014/main" id="{09B1B116-57A3-4233-96B1-D29902583417}"/>
+                <a16:creationId xmlns:a16="http://schemas.microsoft.com/office/drawing/2014/main" id="{22571115-7CCC-4A4E-AF6A-E6DD1F63BC60}"/>
               </a:ext>
             </a:extLst>
           </p:cNvPr>
@@ -1907,7 +1907,7 @@
           <p:cNvPr id="6" name="">
             <a:extLst xmlns:a="http://schemas.openxmlformats.org/drawingml/2006/main">
               <a:ext uri="{FF2B5EF4-FFF2-40B4-BE49-F238E27FC236}">
-                <a16:creationId xmlns:a16="http://schemas.microsoft.com/office/drawing/2014/main" id="{FBE82C8A-7370-4EBD-B3E0-384410642F5F}"/>
+                <a16:creationId xmlns:a16="http://schemas.microsoft.com/office/drawing/2014/main" id="{9DA9906F-4A2D-4F50-A4B1-25C25E00617D}"/>
               </a:ext>
             </a:extLst>
           </p:cNvPr>
@@ -1964,7 +1964,7 @@
           <p:cNvPr id="7" name="">
             <a:extLst xmlns:a="http://schemas.openxmlformats.org/drawingml/2006/main">
               <a:ext uri="{FF2B5EF4-FFF2-40B4-BE49-F238E27FC236}">
-                <a16:creationId xmlns:a16="http://schemas.microsoft.com/office/drawing/2014/main" id="{0F98DCA0-8AF7-4DED-AEA9-F5DE2E8D4354}"/>
+                <a16:creationId xmlns:a16="http://schemas.microsoft.com/office/drawing/2014/main" id="{B072F18C-778B-4C34-953E-11E13A2DD80A}"/>
               </a:ext>
             </a:extLst>
           </p:cNvPr>
@@ -2021,7 +2021,7 @@
           <p:cNvPr id="8" name="">
             <a:extLst xmlns:a="http://schemas.openxmlformats.org/drawingml/2006/main">
               <a:ext uri="{FF2B5EF4-FFF2-40B4-BE49-F238E27FC236}">
-                <a16:creationId xmlns:a16="http://schemas.microsoft.com/office/drawing/2014/main" id="{9BAFC16C-7A14-4A9A-9B9A-24D88E19B635}"/>
+                <a16:creationId xmlns:a16="http://schemas.microsoft.com/office/drawing/2014/main" id="{C678F292-32CE-4D18-AFA6-13E354577A80}"/>
               </a:ext>
             </a:extLst>
           </p:cNvPr>
@@ -2068,7 +2068,7 @@
                 <a:ea typeface="Arial"/>
                 <a:cs typeface="Arial"/>
               </a:rPr>
-              <a:t>Sources bottles and prepares a checkout handoff</a:t>
+              <a:t>Sources a product-only bottle price range</a:t>
             </a:r>
           </a:p>
         </p:txBody>
@@ -2078,7 +2078,7 @@
           <p:cNvPr id="9" name="">
             <a:extLst xmlns:a="http://schemas.openxmlformats.org/drawingml/2006/main">
               <a:ext uri="{FF2B5EF4-FFF2-40B4-BE49-F238E27FC236}">
-                <a16:creationId xmlns:a16="http://schemas.microsoft.com/office/drawing/2014/main" id="{C743A4A5-C226-4DEF-B89E-CC5BE9C2A3C3}"/>
+                <a16:creationId xmlns:a16="http://schemas.microsoft.com/office/drawing/2014/main" id="{7EC031B3-365E-4AE8-9115-3FE57A8919E8}"/>
               </a:ext>
             </a:extLst>
           </p:cNvPr>
@@ -2135,7 +2135,7 @@
           <p:cNvPr id="10" name="">
             <a:extLst xmlns:a="http://schemas.openxmlformats.org/drawingml/2006/main">
               <a:ext uri="{FF2B5EF4-FFF2-40B4-BE49-F238E27FC236}">
-                <a16:creationId xmlns:a16="http://schemas.microsoft.com/office/drawing/2014/main" id="{6DB49783-84BC-45F4-ADA5-4B51AA40FB22}"/>
+                <a16:creationId xmlns:a16="http://schemas.microsoft.com/office/drawing/2014/main" id="{CB4E1DF1-EA8F-438D-A2C7-6050588AF5D0}"/>
               </a:ext>
             </a:extLst>
           </p:cNvPr>
@@ -2182,7 +2182,7 @@
                 <a:ea typeface="Arial"/>
                 <a:cs typeface="Arial"/>
               </a:rPr>
-              <a:t>Records the estimate, budget and purchase reason</a:t>
+              <a:t>Records the estimate, budget and why bottles were requested</a:t>
             </a:r>
           </a:p>
         </p:txBody>
@@ -2192,7 +2192,7 @@
           <p:cNvPr id="11" name="">
             <a:extLst xmlns:a="http://schemas.openxmlformats.org/drawingml/2006/main">
               <a:ext uri="{FF2B5EF4-FFF2-40B4-BE49-F238E27FC236}">
-                <a16:creationId xmlns:a16="http://schemas.microsoft.com/office/drawing/2014/main" id="{30AD8D06-7211-46F8-8E62-A801E0A38E8F}"/>
+                <a16:creationId xmlns:a16="http://schemas.microsoft.com/office/drawing/2014/main" id="{E1862F65-3FC9-4216-B1DC-F2E94B73A6DB}"/>
               </a:ext>
             </a:extLst>
           </p:cNvPr>
@@ -2262,7 +2262,7 @@
                 <a:ea typeface="Arial"/>
                 <a:cs typeface="Arial"/>
               </a:rPr>
-              <a:t>The updated $486.00–$561.84 product-only estimate is not a payment.</a:t>
+              <a:t>Checkout remains unavailable; $486.00–$561.84 is a product-only estimate.</a:t>
             </a:r>
           </a:p>
         </p:txBody>
@@ -2270,7 +2270,7 @@
     </p:spTree>
     <p:extLst>
       <p:ext uri="{BB962C8B-B14F-4D97-AF65-F5344CB8AC3E}">
-        <p14:creationId xmlns:p14="http://schemas.microsoft.com/office/powerpoint/2010/main" val="357911081"/>
+        <p14:creationId xmlns:p14="http://schemas.microsoft.com/office/powerpoint/2010/main" val="1224280558"/>
       </p:ext>
     </p:extLst>
   </p:cSld>
@@ -2301,7 +2301,7 @@
           <p:cNvPr id="8" name="">
             <a:extLst xmlns:a="http://schemas.openxmlformats.org/drawingml/2006/main">
               <a:ext uri="{FF2B5EF4-FFF2-40B4-BE49-F238E27FC236}">
-                <a16:creationId xmlns:a16="http://schemas.microsoft.com/office/drawing/2014/main" id="{3ABBF296-FBCA-4381-B72C-5C88D346B1E3}"/>
+                <a16:creationId xmlns:a16="http://schemas.microsoft.com/office/drawing/2014/main" id="{37359B44-C653-40DC-82B5-39EC9A01A28C}"/>
               </a:ext>
             </a:extLst>
           </p:cNvPr>
@@ -2358,7 +2358,7 @@
           <p:cNvPr id="2" name="">
             <a:extLst xmlns:a="http://schemas.openxmlformats.org/drawingml/2006/main">
               <a:ext uri="{FF2B5EF4-FFF2-40B4-BE49-F238E27FC236}">
-                <a16:creationId xmlns:a16="http://schemas.microsoft.com/office/drawing/2014/main" id="{EDE80E16-49FA-4F8F-A28F-F43DC2868260}"/>
+                <a16:creationId xmlns:a16="http://schemas.microsoft.com/office/drawing/2014/main" id="{3FB4EE35-0420-4850-B317-274513FE90C6}"/>
               </a:ext>
             </a:extLst>
           </p:cNvPr>
@@ -2415,7 +2415,7 @@
           <p:cNvPr id="3" name="">
             <a:extLst xmlns:a="http://schemas.openxmlformats.org/drawingml/2006/main">
               <a:ext uri="{FF2B5EF4-FFF2-40B4-BE49-F238E27FC236}">
-                <a16:creationId xmlns:a16="http://schemas.microsoft.com/office/drawing/2014/main" id="{83E42C81-C98B-4C55-B38D-AEC1C2DC02E6}"/>
+                <a16:creationId xmlns:a16="http://schemas.microsoft.com/office/drawing/2014/main" id="{8985A865-428B-49E5-BE1E-A149E0A989B5}"/>
               </a:ext>
             </a:extLst>
           </p:cNvPr>
@@ -2518,7 +2518,7 @@
           <p:cNvPr id="4" name="">
             <a:extLst xmlns:a="http://schemas.openxmlformats.org/drawingml/2006/main">
               <a:ext uri="{FF2B5EF4-FFF2-40B4-BE49-F238E27FC236}">
-                <a16:creationId xmlns:a16="http://schemas.microsoft.com/office/drawing/2014/main" id="{CC3ED79D-D423-4DCA-A6EF-F02B08297DB5}"/>
+                <a16:creationId xmlns:a16="http://schemas.microsoft.com/office/drawing/2014/main" id="{C6372C1F-3779-47A4-A836-3CE645D16DA2}"/>
               </a:ext>
             </a:extLst>
           </p:cNvPr>
@@ -2575,7 +2575,7 @@
           <p:cNvPr id="5" name="">
             <a:extLst xmlns:a="http://schemas.openxmlformats.org/drawingml/2006/main">
               <a:ext uri="{FF2B5EF4-FFF2-40B4-BE49-F238E27FC236}">
-                <a16:creationId xmlns:a16="http://schemas.microsoft.com/office/drawing/2014/main" id="{D6914ECF-8557-40BD-868D-9D15B41B92D8}"/>
+                <a16:creationId xmlns:a16="http://schemas.microsoft.com/office/drawing/2014/main" id="{D295F782-C1A3-41E1-987F-6083518AD73E}"/>
               </a:ext>
             </a:extLst>
           </p:cNvPr>
@@ -2678,7 +2678,7 @@
           <p:cNvPr id="6" name="">
             <a:extLst xmlns:a="http://schemas.openxmlformats.org/drawingml/2006/main">
               <a:ext uri="{FF2B5EF4-FFF2-40B4-BE49-F238E27FC236}">
-                <a16:creationId xmlns:a16="http://schemas.microsoft.com/office/drawing/2014/main" id="{5CF6E280-C39E-4238-A31B-1186D998E34F}"/>
+                <a16:creationId xmlns:a16="http://schemas.microsoft.com/office/drawing/2014/main" id="{538C209B-DC26-4CD1-8A3A-F31667091BAA}"/>
               </a:ext>
             </a:extLst>
           </p:cNvPr>
@@ -2735,7 +2735,7 @@
           <p:cNvPr id="7" name="">
             <a:extLst xmlns:a="http://schemas.openxmlformats.org/drawingml/2006/main">
               <a:ext uri="{FF2B5EF4-FFF2-40B4-BE49-F238E27FC236}">
-                <a16:creationId xmlns:a16="http://schemas.microsoft.com/office/drawing/2014/main" id="{B5986A92-F213-4E4E-BDAA-6382F6D6B80E}"/>
+                <a16:creationId xmlns:a16="http://schemas.microsoft.com/office/drawing/2014/main" id="{7A4F1EE9-1224-499C-AB62-286B7FEFE0A0}"/>
               </a:ext>
             </a:extLst>
           </p:cNvPr>
@@ -2790,7 +2790,7 @@
     </p:spTree>
     <p:extLst>
       <p:ext uri="{BB962C8B-B14F-4D97-AF65-F5344CB8AC3E}">
-        <p14:creationId xmlns:p14="http://schemas.microsoft.com/office/powerpoint/2010/main" val="1799779619"/>
+        <p14:creationId xmlns:p14="http://schemas.microsoft.com/office/powerpoint/2010/main" val="1672170195"/>
       </p:ext>
     </p:extLst>
   </p:cSld>
@@ -2821,7 +2821,7 @@
           <p:cNvPr id="10" name="">
             <a:extLst xmlns:a="http://schemas.openxmlformats.org/drawingml/2006/main">
               <a:ext uri="{FF2B5EF4-FFF2-40B4-BE49-F238E27FC236}">
-                <a16:creationId xmlns:a16="http://schemas.microsoft.com/office/drawing/2014/main" id="{3B30E451-9B3F-46CA-B6F3-65D8B62FE233}"/>
+                <a16:creationId xmlns:a16="http://schemas.microsoft.com/office/drawing/2014/main" id="{2477C99A-8234-4F9C-91A6-C9105A8F1805}"/>
               </a:ext>
             </a:extLst>
           </p:cNvPr>
@@ -2878,7 +2878,7 @@
           <p:cNvPr id="2" name="">
             <a:extLst xmlns:a="http://schemas.openxmlformats.org/drawingml/2006/main">
               <a:ext uri="{FF2B5EF4-FFF2-40B4-BE49-F238E27FC236}">
-                <a16:creationId xmlns:a16="http://schemas.microsoft.com/office/drawing/2014/main" id="{5BDA8C01-DC64-4351-A144-34086AFF81DB}"/>
+                <a16:creationId xmlns:a16="http://schemas.microsoft.com/office/drawing/2014/main" id="{4AA0BAE5-66A3-42B5-89F2-666123AE55E9}"/>
               </a:ext>
             </a:extLst>
           </p:cNvPr>
@@ -2935,7 +2935,7 @@
           <p:cNvPr id="3" name="">
             <a:extLst xmlns:a="http://schemas.openxmlformats.org/drawingml/2006/main">
               <a:ext uri="{FF2B5EF4-FFF2-40B4-BE49-F238E27FC236}">
-                <a16:creationId xmlns:a16="http://schemas.microsoft.com/office/drawing/2014/main" id="{4D8A05D0-C02E-4176-B078-F37A0A698AE8}"/>
+                <a16:creationId xmlns:a16="http://schemas.microsoft.com/office/drawing/2014/main" id="{C8E17B34-6CDC-4ED7-B4B2-97DCF6279247}"/>
               </a:ext>
             </a:extLst>
           </p:cNvPr>
@@ -3015,7 +3015,7 @@
           <p:cNvPr id="4" name="">
             <a:extLst xmlns:a="http://schemas.openxmlformats.org/drawingml/2006/main">
               <a:ext uri="{FF2B5EF4-FFF2-40B4-BE49-F238E27FC236}">
-                <a16:creationId xmlns:a16="http://schemas.microsoft.com/office/drawing/2014/main" id="{0E594921-4BAD-4269-A095-F1ABFE472593}"/>
+                <a16:creationId xmlns:a16="http://schemas.microsoft.com/office/drawing/2014/main" id="{84310B55-5DC4-48AB-9122-FC456E9FC0BD}"/>
               </a:ext>
             </a:extLst>
           </p:cNvPr>
@@ -3072,7 +3072,7 @@
           <p:cNvPr id="5" name="">
             <a:extLst xmlns:a="http://schemas.openxmlformats.org/drawingml/2006/main">
               <a:ext uri="{FF2B5EF4-FFF2-40B4-BE49-F238E27FC236}">
-                <a16:creationId xmlns:a16="http://schemas.microsoft.com/office/drawing/2014/main" id="{63E4F6B3-1EE1-40D4-8B67-60E3FBFEC461}"/>
+                <a16:creationId xmlns:a16="http://schemas.microsoft.com/office/drawing/2014/main" id="{E5A61257-D371-4DC0-9A4A-EB552B1067F3}"/>
               </a:ext>
             </a:extLst>
           </p:cNvPr>
@@ -3198,7 +3198,7 @@
           <p:cNvPr id="6" name="">
             <a:extLst xmlns:a="http://schemas.openxmlformats.org/drawingml/2006/main">
               <a:ext uri="{FF2B5EF4-FFF2-40B4-BE49-F238E27FC236}">
-                <a16:creationId xmlns:a16="http://schemas.microsoft.com/office/drawing/2014/main" id="{0D6DE224-EF96-48EA-929F-C6A6360E6AB1}"/>
+                <a16:creationId xmlns:a16="http://schemas.microsoft.com/office/drawing/2014/main" id="{46B6250F-CBC8-4F7B-84F5-139372960AF8}"/>
               </a:ext>
             </a:extLst>
           </p:cNvPr>
@@ -3255,7 +3255,7 @@
           <p:cNvPr id="7" name="">
             <a:extLst xmlns:a="http://schemas.openxmlformats.org/drawingml/2006/main">
               <a:ext uri="{FF2B5EF4-FFF2-40B4-BE49-F238E27FC236}">
-                <a16:creationId xmlns:a16="http://schemas.microsoft.com/office/drawing/2014/main" id="{A35D1B3B-9EEC-45FF-A97E-32B58F450AFE}"/>
+                <a16:creationId xmlns:a16="http://schemas.microsoft.com/office/drawing/2014/main" id="{C01909B3-0528-45E5-9846-F5E64F3EDA32}"/>
               </a:ext>
             </a:extLst>
           </p:cNvPr>
@@ -3381,7 +3381,7 @@
           <p:cNvPr id="8" name="">
             <a:extLst xmlns:a="http://schemas.openxmlformats.org/drawingml/2006/main">
               <a:ext uri="{FF2B5EF4-FFF2-40B4-BE49-F238E27FC236}">
-                <a16:creationId xmlns:a16="http://schemas.microsoft.com/office/drawing/2014/main" id="{21015E63-C75C-4E1A-8196-0224C93434CD}"/>
+                <a16:creationId xmlns:a16="http://schemas.microsoft.com/office/drawing/2014/main" id="{FEFBC681-9C25-458A-A5E0-B59795917D4D}"/>
               </a:ext>
             </a:extLst>
           </p:cNvPr>
@@ -3451,7 +3451,7 @@
                 <a:ea typeface="Arial"/>
                 <a:cs typeface="Arial"/>
               </a:rPr>
-              <a:t>Lab: 42 / exit 124 / 42 with zero leftover containers. No booking, purchase or invitations.</a:t>
+              <a:t>Lab: 42 / exit 124 / 42 with zero leftover containers. No venue booked, order placed or invitations sent.</a:t>
             </a:r>
           </a:p>
         </p:txBody>
@@ -3461,7 +3461,7 @@
           <p:cNvPr id="9" name="">
             <a:extLst xmlns:a="http://schemas.openxmlformats.org/drawingml/2006/main">
               <a:ext uri="{FF2B5EF4-FFF2-40B4-BE49-F238E27FC236}">
-                <a16:creationId xmlns:a16="http://schemas.microsoft.com/office/drawing/2014/main" id="{74C7C245-5AA7-46E3-A5A3-6473CA6D91BC}"/>
+                <a16:creationId xmlns:a16="http://schemas.microsoft.com/office/drawing/2014/main" id="{C54E75D7-9B2F-4EAE-86E7-48718EE31628}"/>
               </a:ext>
             </a:extLst>
           </p:cNvPr>
@@ -3516,7 +3516,7 @@
     </p:spTree>
     <p:extLst>
       <p:ext uri="{BB962C8B-B14F-4D97-AF65-F5344CB8AC3E}">
-        <p14:creationId xmlns:p14="http://schemas.microsoft.com/office/powerpoint/2010/main" val="1295579493"/>
+        <p14:creationId xmlns:p14="http://schemas.microsoft.com/office/powerpoint/2010/main" val="671831814"/>
       </p:ext>
     </p:extLst>
   </p:cSld>
@@ -3547,7 +3547,7 @@
           <p:cNvPr id="7" name="">
             <a:extLst xmlns:a="http://schemas.openxmlformats.org/drawingml/2006/main">
               <a:ext uri="{FF2B5EF4-FFF2-40B4-BE49-F238E27FC236}">
-                <a16:creationId xmlns:a16="http://schemas.microsoft.com/office/drawing/2014/main" id="{0D4A121C-2FC5-45FE-B8F4-85415BB79581}"/>
+                <a16:creationId xmlns:a16="http://schemas.microsoft.com/office/drawing/2014/main" id="{5214154B-4AA9-43FE-95A4-927F27F6B6F2}"/>
               </a:ext>
             </a:extLst>
           </p:cNvPr>
@@ -3604,7 +3604,7 @@
           <p:cNvPr id="2" name="">
             <a:extLst xmlns:a="http://schemas.openxmlformats.org/drawingml/2006/main">
               <a:ext uri="{FF2B5EF4-FFF2-40B4-BE49-F238E27FC236}">
-                <a16:creationId xmlns:a16="http://schemas.microsoft.com/office/drawing/2014/main" id="{7912291E-7CF0-479B-901C-CFBE6B9B577D}"/>
+                <a16:creationId xmlns:a16="http://schemas.microsoft.com/office/drawing/2014/main" id="{E81EB9C9-B6F1-47D1-92BD-97B7D3229D94}"/>
               </a:ext>
             </a:extLst>
           </p:cNvPr>
@@ -3661,7 +3661,7 @@
           <p:cNvPr id="3" name="">
             <a:extLst xmlns:a="http://schemas.openxmlformats.org/drawingml/2006/main">
               <a:ext uri="{FF2B5EF4-FFF2-40B4-BE49-F238E27FC236}">
-                <a16:creationId xmlns:a16="http://schemas.microsoft.com/office/drawing/2014/main" id="{B7E4F705-8A3F-4A34-B519-D22D64D197C3}"/>
+                <a16:creationId xmlns:a16="http://schemas.microsoft.com/office/drawing/2014/main" id="{45574CBB-D876-4DB9-B0D8-533EDFE5AFBD}"/>
               </a:ext>
             </a:extLst>
           </p:cNvPr>
@@ -3718,7 +3718,7 @@
           <p:cNvPr id="4" name="">
             <a:extLst xmlns:a="http://schemas.openxmlformats.org/drawingml/2006/main">
               <a:ext uri="{FF2B5EF4-FFF2-40B4-BE49-F238E27FC236}">
-                <a16:creationId xmlns:a16="http://schemas.microsoft.com/office/drawing/2014/main" id="{436CC618-3FB2-481E-A9BC-C6983AC99AA4}"/>
+                <a16:creationId xmlns:a16="http://schemas.microsoft.com/office/drawing/2014/main" id="{FAD1280A-DB30-4FDD-B976-72A36F776441}"/>
               </a:ext>
             </a:extLst>
           </p:cNvPr>
@@ -3775,7 +3775,7 @@
           <p:cNvPr id="5" name="">
             <a:extLst xmlns:a="http://schemas.openxmlformats.org/drawingml/2006/main">
               <a:ext uri="{FF2B5EF4-FFF2-40B4-BE49-F238E27FC236}">
-                <a16:creationId xmlns:a16="http://schemas.microsoft.com/office/drawing/2014/main" id="{145E5002-41FF-47A2-8252-99AB933EF26A}"/>
+                <a16:creationId xmlns:a16="http://schemas.microsoft.com/office/drawing/2014/main" id="{D88ACF2E-30ED-46A4-AE0C-C291869D41F6}"/>
               </a:ext>
             </a:extLst>
           </p:cNvPr>
@@ -3832,7 +3832,7 @@
           <p:cNvPr id="6" name="">
             <a:extLst xmlns:a="http://schemas.openxmlformats.org/drawingml/2006/main">
               <a:ext uri="{FF2B5EF4-FFF2-40B4-BE49-F238E27FC236}">
-                <a16:creationId xmlns:a16="http://schemas.microsoft.com/office/drawing/2014/main" id="{800AE8D8-78F5-42CE-8CB2-EC5C489A742E}"/>
+                <a16:creationId xmlns:a16="http://schemas.microsoft.com/office/drawing/2014/main" id="{10616B5C-CD4D-4535-A270-C7C5127D57F9}"/>
               </a:ext>
             </a:extLst>
           </p:cNvPr>
@@ -3887,7 +3887,7 @@
     </p:spTree>
     <p:extLst>
       <p:ext uri="{BB962C8B-B14F-4D97-AF65-F5344CB8AC3E}">
-        <p14:creationId xmlns:p14="http://schemas.microsoft.com/office/powerpoint/2010/main" val="1411032292"/>
+        <p14:creationId xmlns:p14="http://schemas.microsoft.com/office/powerpoint/2010/main" val="1049385193"/>
       </p:ext>
     </p:extLst>
   </p:cSld>

</xml_diff>

<commit_message>
Clarify private judge token delivery is pending
</commit_message>
<xml_diff>
--- a/assets/deck/pengwin-agent-arena-submission.pptx
+++ b/assets/deck/pengwin-agent-arena-submission.pptx
@@ -2,17 +2,17 @@
 <file path=ppt/presentation.xml><?xml version="1.0" encoding="utf-8"?>
 <p:presentation xmlns:p="http://schemas.openxmlformats.org/presentationml/2006/main">
   <p:sldMasterIdLst>
-    <p:sldMasterId xmlns:r="http://schemas.openxmlformats.org/officeDocument/2006/relationships" id="2147483648" r:id="R6214d1d72cdc4db9"/>
+    <p:sldMasterId xmlns:r="http://schemas.openxmlformats.org/officeDocument/2006/relationships" id="2147483648" r:id="R0635b423f26e4c2a"/>
   </p:sldMasterIdLst>
   <p:notesMasterIdLst>
-    <p:notesMasterId xmlns:r="http://schemas.openxmlformats.org/officeDocument/2006/relationships" r:id="Re57161d2596740a1"/>
+    <p:notesMasterId xmlns:r="http://schemas.openxmlformats.org/officeDocument/2006/relationships" r:id="Ra50f6f03b8db477e"/>
   </p:notesMasterIdLst>
   <p:sldIdLst>
-    <p:sldId xmlns:r="http://schemas.openxmlformats.org/officeDocument/2006/relationships" id="256" r:id="R27e020ad42584af9"/>
-    <p:sldId xmlns:r="http://schemas.openxmlformats.org/officeDocument/2006/relationships" id="257" r:id="R29c4ba5718dc4a2f"/>
-    <p:sldId xmlns:r="http://schemas.openxmlformats.org/officeDocument/2006/relationships" id="258" r:id="Ra72ac14c85f241df"/>
-    <p:sldId xmlns:r="http://schemas.openxmlformats.org/officeDocument/2006/relationships" id="259" r:id="Reca9889c44ac428a"/>
-    <p:sldId xmlns:r="http://schemas.openxmlformats.org/officeDocument/2006/relationships" id="260" r:id="Rb286375701fa4723"/>
+    <p:sldId xmlns:r="http://schemas.openxmlformats.org/officeDocument/2006/relationships" id="256" r:id="Rd8ddaf2cec3d49c0"/>
+    <p:sldId xmlns:r="http://schemas.openxmlformats.org/officeDocument/2006/relationships" id="257" r:id="Rd0b9d7f4a6df41a9"/>
+    <p:sldId xmlns:r="http://schemas.openxmlformats.org/officeDocument/2006/relationships" id="258" r:id="R730449667bab4b96"/>
+    <p:sldId xmlns:r="http://schemas.openxmlformats.org/officeDocument/2006/relationships" id="259" r:id="R9d4d32451299406b"/>
+    <p:sldId xmlns:r="http://schemas.openxmlformats.org/officeDocument/2006/relationships" id="260" r:id="R09924dbb434b46a3"/>
   </p:sldIdLst>
   <p:sldSz cx="12192000" cy="6858000"/>
   <p:notesSz cx="6858000" cy="9144000"/>
@@ -814,7 +814,7 @@
   </p:cSld>
   <p:clrMap bg1="lt1" tx1="dk1" bg2="lt2" tx2="dk2" accent1="accent1" accent2="accent2" accent3="accent3" accent4="accent4" accent5="accent5" accent6="accent6" hlink="hlink" folHlink="folHlink"/>
   <p:sldLayoutIdLst>
-    <p:sldLayoutId xmlns:r="http://schemas.openxmlformats.org/officeDocument/2006/relationships" id="2147483649" r:id="R8e9be837b13f43e2"/>
+    <p:sldLayoutId xmlns:r="http://schemas.openxmlformats.org/officeDocument/2006/relationships" id="2147483649" r:id="Rfd2b702c986746fb"/>
   </p:sldLayoutIdLst>
   <p:txStyles>
     <p:titleStyle>
@@ -1365,7 +1365,7 @@
           <p:cNvPr id="5" name="">
             <a:extLst xmlns:a="http://schemas.openxmlformats.org/drawingml/2006/main">
               <a:ext uri="{FF2B5EF4-FFF2-40B4-BE49-F238E27FC236}">
-                <a16:creationId xmlns:a16="http://schemas.microsoft.com/office/drawing/2014/main" id="{C85A6A1F-0148-413D-8D1C-97C68F45A5A8}"/>
+                <a16:creationId xmlns:a16="http://schemas.microsoft.com/office/drawing/2014/main" id="{ECD40363-A897-49F9-9D44-DA36FDA30AB6}"/>
               </a:ext>
             </a:extLst>
           </p:cNvPr>
@@ -1422,7 +1422,7 @@
           <p:cNvPr id="2" name="">
             <a:extLst xmlns:a="http://schemas.openxmlformats.org/drawingml/2006/main">
               <a:ext uri="{FF2B5EF4-FFF2-40B4-BE49-F238E27FC236}">
-                <a16:creationId xmlns:a16="http://schemas.microsoft.com/office/drawing/2014/main" id="{1F042C14-EC64-43B9-BA08-D844C7E874DB}"/>
+                <a16:creationId xmlns:a16="http://schemas.microsoft.com/office/drawing/2014/main" id="{B77621C3-DBB7-4FE9-AD01-6000A52A1CA6}"/>
               </a:ext>
             </a:extLst>
           </p:cNvPr>
@@ -1479,7 +1479,7 @@
           <p:cNvPr id="3" name="">
             <a:extLst xmlns:a="http://schemas.openxmlformats.org/drawingml/2006/main">
               <a:ext uri="{FF2B5EF4-FFF2-40B4-BE49-F238E27FC236}">
-                <a16:creationId xmlns:a16="http://schemas.microsoft.com/office/drawing/2014/main" id="{DA63401C-B149-47BC-BA82-48ED829DEDA3}"/>
+                <a16:creationId xmlns:a16="http://schemas.microsoft.com/office/drawing/2014/main" id="{9DD2A8B0-DE82-4E89-BDD4-A7C714DB7CEB}"/>
               </a:ext>
             </a:extLst>
           </p:cNvPr>
@@ -1536,7 +1536,7 @@
           <p:cNvPr id="4" name="">
             <a:extLst xmlns:a="http://schemas.openxmlformats.org/drawingml/2006/main">
               <a:ext uri="{FF2B5EF4-FFF2-40B4-BE49-F238E27FC236}">
-                <a16:creationId xmlns:a16="http://schemas.microsoft.com/office/drawing/2014/main" id="{8D13D39B-42AF-4CF4-86E6-4F333E92AB75}"/>
+                <a16:creationId xmlns:a16="http://schemas.microsoft.com/office/drawing/2014/main" id="{CBD5B797-0A02-4D11-A092-F2C87784815E}"/>
               </a:ext>
             </a:extLst>
           </p:cNvPr>
@@ -1591,7 +1591,7 @@
     </p:spTree>
     <p:extLst>
       <p:ext uri="{BB962C8B-B14F-4D97-AF65-F5344CB8AC3E}">
-        <p14:creationId xmlns:p14="http://schemas.microsoft.com/office/powerpoint/2010/main" val="1096281689"/>
+        <p14:creationId xmlns:p14="http://schemas.microsoft.com/office/powerpoint/2010/main" val="622067891"/>
       </p:ext>
     </p:extLst>
   </p:cSld>
@@ -1622,7 +1622,7 @@
           <p:cNvPr id="12" name="">
             <a:extLst xmlns:a="http://schemas.openxmlformats.org/drawingml/2006/main">
               <a:ext uri="{FF2B5EF4-FFF2-40B4-BE49-F238E27FC236}">
-                <a16:creationId xmlns:a16="http://schemas.microsoft.com/office/drawing/2014/main" id="{314C2881-8F58-4717-8F95-A5F10FC917EE}"/>
+                <a16:creationId xmlns:a16="http://schemas.microsoft.com/office/drawing/2014/main" id="{D23AE3F0-611A-4E04-86B5-DE5F8AD87ADA}"/>
               </a:ext>
             </a:extLst>
           </p:cNvPr>
@@ -1679,7 +1679,7 @@
           <p:cNvPr id="2" name="">
             <a:extLst xmlns:a="http://schemas.openxmlformats.org/drawingml/2006/main">
               <a:ext uri="{FF2B5EF4-FFF2-40B4-BE49-F238E27FC236}">
-                <a16:creationId xmlns:a16="http://schemas.microsoft.com/office/drawing/2014/main" id="{F4AF4BD4-2484-47AC-8066-2595179F1D81}"/>
+                <a16:creationId xmlns:a16="http://schemas.microsoft.com/office/drawing/2014/main" id="{E8778BB5-0E23-402A-81E7-A95F4DA457EE}"/>
               </a:ext>
             </a:extLst>
           </p:cNvPr>
@@ -1736,7 +1736,7 @@
           <p:cNvPr id="3" name="">
             <a:extLst xmlns:a="http://schemas.openxmlformats.org/drawingml/2006/main">
               <a:ext uri="{FF2B5EF4-FFF2-40B4-BE49-F238E27FC236}">
-                <a16:creationId xmlns:a16="http://schemas.microsoft.com/office/drawing/2014/main" id="{50E7E6FA-F2BA-48C6-972C-1E8801D05CFD}"/>
+                <a16:creationId xmlns:a16="http://schemas.microsoft.com/office/drawing/2014/main" id="{12AB0A72-F8B1-4F5A-A888-E4034E60FCE7}"/>
               </a:ext>
             </a:extLst>
           </p:cNvPr>
@@ -1793,7 +1793,7 @@
           <p:cNvPr id="4" name="">
             <a:extLst xmlns:a="http://schemas.openxmlformats.org/drawingml/2006/main">
               <a:ext uri="{FF2B5EF4-FFF2-40B4-BE49-F238E27FC236}">
-                <a16:creationId xmlns:a16="http://schemas.microsoft.com/office/drawing/2014/main" id="{0BDB0448-2D0E-4C60-B36F-9EA88B094968}"/>
+                <a16:creationId xmlns:a16="http://schemas.microsoft.com/office/drawing/2014/main" id="{4F82CFE9-A4CD-4993-8345-0A7CA30C008C}"/>
               </a:ext>
             </a:extLst>
           </p:cNvPr>
@@ -1850,7 +1850,7 @@
           <p:cNvPr id="5" name="">
             <a:extLst xmlns:a="http://schemas.openxmlformats.org/drawingml/2006/main">
               <a:ext uri="{FF2B5EF4-FFF2-40B4-BE49-F238E27FC236}">
-                <a16:creationId xmlns:a16="http://schemas.microsoft.com/office/drawing/2014/main" id="{22571115-7CCC-4A4E-AF6A-E6DD1F63BC60}"/>
+                <a16:creationId xmlns:a16="http://schemas.microsoft.com/office/drawing/2014/main" id="{37128CC3-8D0D-4732-8A78-CFCE5C913198}"/>
               </a:ext>
             </a:extLst>
           </p:cNvPr>
@@ -1907,7 +1907,7 @@
           <p:cNvPr id="6" name="">
             <a:extLst xmlns:a="http://schemas.openxmlformats.org/drawingml/2006/main">
               <a:ext uri="{FF2B5EF4-FFF2-40B4-BE49-F238E27FC236}">
-                <a16:creationId xmlns:a16="http://schemas.microsoft.com/office/drawing/2014/main" id="{9DA9906F-4A2D-4F50-A4B1-25C25E00617D}"/>
+                <a16:creationId xmlns:a16="http://schemas.microsoft.com/office/drawing/2014/main" id="{C9C5F529-3FCC-4521-A8D1-14D17831C310}"/>
               </a:ext>
             </a:extLst>
           </p:cNvPr>
@@ -1964,7 +1964,7 @@
           <p:cNvPr id="7" name="">
             <a:extLst xmlns:a="http://schemas.openxmlformats.org/drawingml/2006/main">
               <a:ext uri="{FF2B5EF4-FFF2-40B4-BE49-F238E27FC236}">
-                <a16:creationId xmlns:a16="http://schemas.microsoft.com/office/drawing/2014/main" id="{B072F18C-778B-4C34-953E-11E13A2DD80A}"/>
+                <a16:creationId xmlns:a16="http://schemas.microsoft.com/office/drawing/2014/main" id="{B831DEC3-A26C-44BD-A835-2D1933B55503}"/>
               </a:ext>
             </a:extLst>
           </p:cNvPr>
@@ -2021,7 +2021,7 @@
           <p:cNvPr id="8" name="">
             <a:extLst xmlns:a="http://schemas.openxmlformats.org/drawingml/2006/main">
               <a:ext uri="{FF2B5EF4-FFF2-40B4-BE49-F238E27FC236}">
-                <a16:creationId xmlns:a16="http://schemas.microsoft.com/office/drawing/2014/main" id="{C678F292-32CE-4D18-AFA6-13E354577A80}"/>
+                <a16:creationId xmlns:a16="http://schemas.microsoft.com/office/drawing/2014/main" id="{700C0D65-9D17-49EF-A8C4-A1917A87E777}"/>
               </a:ext>
             </a:extLst>
           </p:cNvPr>
@@ -2078,7 +2078,7 @@
           <p:cNvPr id="9" name="">
             <a:extLst xmlns:a="http://schemas.openxmlformats.org/drawingml/2006/main">
               <a:ext uri="{FF2B5EF4-FFF2-40B4-BE49-F238E27FC236}">
-                <a16:creationId xmlns:a16="http://schemas.microsoft.com/office/drawing/2014/main" id="{7EC031B3-365E-4AE8-9115-3FE57A8919E8}"/>
+                <a16:creationId xmlns:a16="http://schemas.microsoft.com/office/drawing/2014/main" id="{7620162B-19A9-4885-B763-BF12FF8BC7B7}"/>
               </a:ext>
             </a:extLst>
           </p:cNvPr>
@@ -2135,7 +2135,7 @@
           <p:cNvPr id="10" name="">
             <a:extLst xmlns:a="http://schemas.openxmlformats.org/drawingml/2006/main">
               <a:ext uri="{FF2B5EF4-FFF2-40B4-BE49-F238E27FC236}">
-                <a16:creationId xmlns:a16="http://schemas.microsoft.com/office/drawing/2014/main" id="{CB4E1DF1-EA8F-438D-A2C7-6050588AF5D0}"/>
+                <a16:creationId xmlns:a16="http://schemas.microsoft.com/office/drawing/2014/main" id="{0A2E11BF-D928-49A2-ADC9-623BE3C5F9AA}"/>
               </a:ext>
             </a:extLst>
           </p:cNvPr>
@@ -2192,7 +2192,7 @@
           <p:cNvPr id="11" name="">
             <a:extLst xmlns:a="http://schemas.openxmlformats.org/drawingml/2006/main">
               <a:ext uri="{FF2B5EF4-FFF2-40B4-BE49-F238E27FC236}">
-                <a16:creationId xmlns:a16="http://schemas.microsoft.com/office/drawing/2014/main" id="{E1862F65-3FC9-4216-B1DC-F2E94B73A6DB}"/>
+                <a16:creationId xmlns:a16="http://schemas.microsoft.com/office/drawing/2014/main" id="{C449F08F-E683-4209-AA09-0B6D039DD5C1}"/>
               </a:ext>
             </a:extLst>
           </p:cNvPr>
@@ -2270,7 +2270,7 @@
     </p:spTree>
     <p:extLst>
       <p:ext uri="{BB962C8B-B14F-4D97-AF65-F5344CB8AC3E}">
-        <p14:creationId xmlns:p14="http://schemas.microsoft.com/office/powerpoint/2010/main" val="1224280558"/>
+        <p14:creationId xmlns:p14="http://schemas.microsoft.com/office/powerpoint/2010/main" val="813248384"/>
       </p:ext>
     </p:extLst>
   </p:cSld>
@@ -2301,7 +2301,7 @@
           <p:cNvPr id="8" name="">
             <a:extLst xmlns:a="http://schemas.openxmlformats.org/drawingml/2006/main">
               <a:ext uri="{FF2B5EF4-FFF2-40B4-BE49-F238E27FC236}">
-                <a16:creationId xmlns:a16="http://schemas.microsoft.com/office/drawing/2014/main" id="{37359B44-C653-40DC-82B5-39EC9A01A28C}"/>
+                <a16:creationId xmlns:a16="http://schemas.microsoft.com/office/drawing/2014/main" id="{AD245766-23FD-453E-891C-9A3FCEB40AEF}"/>
               </a:ext>
             </a:extLst>
           </p:cNvPr>
@@ -2358,7 +2358,7 @@
           <p:cNvPr id="2" name="">
             <a:extLst xmlns:a="http://schemas.openxmlformats.org/drawingml/2006/main">
               <a:ext uri="{FF2B5EF4-FFF2-40B4-BE49-F238E27FC236}">
-                <a16:creationId xmlns:a16="http://schemas.microsoft.com/office/drawing/2014/main" id="{3FB4EE35-0420-4850-B317-274513FE90C6}"/>
+                <a16:creationId xmlns:a16="http://schemas.microsoft.com/office/drawing/2014/main" id="{DDC14C1D-537F-4262-8A17-E3ADF9845F51}"/>
               </a:ext>
             </a:extLst>
           </p:cNvPr>
@@ -2415,7 +2415,7 @@
           <p:cNvPr id="3" name="">
             <a:extLst xmlns:a="http://schemas.openxmlformats.org/drawingml/2006/main">
               <a:ext uri="{FF2B5EF4-FFF2-40B4-BE49-F238E27FC236}">
-                <a16:creationId xmlns:a16="http://schemas.microsoft.com/office/drawing/2014/main" id="{8985A865-428B-49E5-BE1E-A149E0A989B5}"/>
+                <a16:creationId xmlns:a16="http://schemas.microsoft.com/office/drawing/2014/main" id="{D519B1D6-641A-40D6-9A4E-8CB2CEA5A4D4}"/>
               </a:ext>
             </a:extLst>
           </p:cNvPr>
@@ -2518,7 +2518,7 @@
           <p:cNvPr id="4" name="">
             <a:extLst xmlns:a="http://schemas.openxmlformats.org/drawingml/2006/main">
               <a:ext uri="{FF2B5EF4-FFF2-40B4-BE49-F238E27FC236}">
-                <a16:creationId xmlns:a16="http://schemas.microsoft.com/office/drawing/2014/main" id="{C6372C1F-3779-47A4-A836-3CE645D16DA2}"/>
+                <a16:creationId xmlns:a16="http://schemas.microsoft.com/office/drawing/2014/main" id="{9BCCC10A-374F-420B-B843-B6C55B5BE821}"/>
               </a:ext>
             </a:extLst>
           </p:cNvPr>
@@ -2575,7 +2575,7 @@
           <p:cNvPr id="5" name="">
             <a:extLst xmlns:a="http://schemas.openxmlformats.org/drawingml/2006/main">
               <a:ext uri="{FF2B5EF4-FFF2-40B4-BE49-F238E27FC236}">
-                <a16:creationId xmlns:a16="http://schemas.microsoft.com/office/drawing/2014/main" id="{D295F782-C1A3-41E1-987F-6083518AD73E}"/>
+                <a16:creationId xmlns:a16="http://schemas.microsoft.com/office/drawing/2014/main" id="{E576AA37-4913-4647-9569-22C2F8B7E058}"/>
               </a:ext>
             </a:extLst>
           </p:cNvPr>
@@ -2678,7 +2678,7 @@
           <p:cNvPr id="6" name="">
             <a:extLst xmlns:a="http://schemas.openxmlformats.org/drawingml/2006/main">
               <a:ext uri="{FF2B5EF4-FFF2-40B4-BE49-F238E27FC236}">
-                <a16:creationId xmlns:a16="http://schemas.microsoft.com/office/drawing/2014/main" id="{538C209B-DC26-4CD1-8A3A-F31667091BAA}"/>
+                <a16:creationId xmlns:a16="http://schemas.microsoft.com/office/drawing/2014/main" id="{3A52C738-47F3-4F26-883B-0DC7D47FFBC1}"/>
               </a:ext>
             </a:extLst>
           </p:cNvPr>
@@ -2735,7 +2735,7 @@
           <p:cNvPr id="7" name="">
             <a:extLst xmlns:a="http://schemas.openxmlformats.org/drawingml/2006/main">
               <a:ext uri="{FF2B5EF4-FFF2-40B4-BE49-F238E27FC236}">
-                <a16:creationId xmlns:a16="http://schemas.microsoft.com/office/drawing/2014/main" id="{7A4F1EE9-1224-499C-AB62-286B7FEFE0A0}"/>
+                <a16:creationId xmlns:a16="http://schemas.microsoft.com/office/drawing/2014/main" id="{0F78C082-CFE8-4FA7-B650-6AC3B8A08DAC}"/>
               </a:ext>
             </a:extLst>
           </p:cNvPr>
@@ -2790,7 +2790,7 @@
     </p:spTree>
     <p:extLst>
       <p:ext uri="{BB962C8B-B14F-4D97-AF65-F5344CB8AC3E}">
-        <p14:creationId xmlns:p14="http://schemas.microsoft.com/office/powerpoint/2010/main" val="1672170195"/>
+        <p14:creationId xmlns:p14="http://schemas.microsoft.com/office/powerpoint/2010/main" val="1335112885"/>
       </p:ext>
     </p:extLst>
   </p:cSld>
@@ -2821,7 +2821,7 @@
           <p:cNvPr id="10" name="">
             <a:extLst xmlns:a="http://schemas.openxmlformats.org/drawingml/2006/main">
               <a:ext uri="{FF2B5EF4-FFF2-40B4-BE49-F238E27FC236}">
-                <a16:creationId xmlns:a16="http://schemas.microsoft.com/office/drawing/2014/main" id="{2477C99A-8234-4F9C-91A6-C9105A8F1805}"/>
+                <a16:creationId xmlns:a16="http://schemas.microsoft.com/office/drawing/2014/main" id="{97B97AAF-35DA-4AD6-BEE5-3B7FA102F00C}"/>
               </a:ext>
             </a:extLst>
           </p:cNvPr>
@@ -2878,7 +2878,7 @@
           <p:cNvPr id="2" name="">
             <a:extLst xmlns:a="http://schemas.openxmlformats.org/drawingml/2006/main">
               <a:ext uri="{FF2B5EF4-FFF2-40B4-BE49-F238E27FC236}">
-                <a16:creationId xmlns:a16="http://schemas.microsoft.com/office/drawing/2014/main" id="{4AA0BAE5-66A3-42B5-89F2-666123AE55E9}"/>
+                <a16:creationId xmlns:a16="http://schemas.microsoft.com/office/drawing/2014/main" id="{BC5A9DE7-7135-44D8-8B07-3EB26AE2EB0A}"/>
               </a:ext>
             </a:extLst>
           </p:cNvPr>
@@ -2935,7 +2935,7 @@
           <p:cNvPr id="3" name="">
             <a:extLst xmlns:a="http://schemas.openxmlformats.org/drawingml/2006/main">
               <a:ext uri="{FF2B5EF4-FFF2-40B4-BE49-F238E27FC236}">
-                <a16:creationId xmlns:a16="http://schemas.microsoft.com/office/drawing/2014/main" id="{C8E17B34-6CDC-4ED7-B4B2-97DCF6279247}"/>
+                <a16:creationId xmlns:a16="http://schemas.microsoft.com/office/drawing/2014/main" id="{9CADAC4F-87F3-4A8C-BC56-F6CB8E36A1BE}"/>
               </a:ext>
             </a:extLst>
           </p:cNvPr>
@@ -3015,7 +3015,7 @@
           <p:cNvPr id="4" name="">
             <a:extLst xmlns:a="http://schemas.openxmlformats.org/drawingml/2006/main">
               <a:ext uri="{FF2B5EF4-FFF2-40B4-BE49-F238E27FC236}">
-                <a16:creationId xmlns:a16="http://schemas.microsoft.com/office/drawing/2014/main" id="{84310B55-5DC4-48AB-9122-FC456E9FC0BD}"/>
+                <a16:creationId xmlns:a16="http://schemas.microsoft.com/office/drawing/2014/main" id="{7D72E360-9E00-4D01-BF3A-D28C95AB40DF}"/>
               </a:ext>
             </a:extLst>
           </p:cNvPr>
@@ -3072,7 +3072,7 @@
           <p:cNvPr id="5" name="">
             <a:extLst xmlns:a="http://schemas.openxmlformats.org/drawingml/2006/main">
               <a:ext uri="{FF2B5EF4-FFF2-40B4-BE49-F238E27FC236}">
-                <a16:creationId xmlns:a16="http://schemas.microsoft.com/office/drawing/2014/main" id="{E5A61257-D371-4DC0-9A4A-EB552B1067F3}"/>
+                <a16:creationId xmlns:a16="http://schemas.microsoft.com/office/drawing/2014/main" id="{DA2B49D9-5D6A-4FB3-A038-6FAB8BF04622}"/>
               </a:ext>
             </a:extLst>
           </p:cNvPr>
@@ -3198,7 +3198,7 @@
           <p:cNvPr id="6" name="">
             <a:extLst xmlns:a="http://schemas.openxmlformats.org/drawingml/2006/main">
               <a:ext uri="{FF2B5EF4-FFF2-40B4-BE49-F238E27FC236}">
-                <a16:creationId xmlns:a16="http://schemas.microsoft.com/office/drawing/2014/main" id="{46B6250F-CBC8-4F7B-84F5-139372960AF8}"/>
+                <a16:creationId xmlns:a16="http://schemas.microsoft.com/office/drawing/2014/main" id="{0EB2B4E2-AB32-4855-B139-FCF2555F47B4}"/>
               </a:ext>
             </a:extLst>
           </p:cNvPr>
@@ -3255,7 +3255,7 @@
           <p:cNvPr id="7" name="">
             <a:extLst xmlns:a="http://schemas.openxmlformats.org/drawingml/2006/main">
               <a:ext uri="{FF2B5EF4-FFF2-40B4-BE49-F238E27FC236}">
-                <a16:creationId xmlns:a16="http://schemas.microsoft.com/office/drawing/2014/main" id="{C01909B3-0528-45E5-9846-F5E64F3EDA32}"/>
+                <a16:creationId xmlns:a16="http://schemas.microsoft.com/office/drawing/2014/main" id="{0F501C84-6EC3-4715-A691-7E7E97E5D6BA}"/>
               </a:ext>
             </a:extLst>
           </p:cNvPr>
@@ -3381,7 +3381,7 @@
           <p:cNvPr id="8" name="">
             <a:extLst xmlns:a="http://schemas.openxmlformats.org/drawingml/2006/main">
               <a:ext uri="{FF2B5EF4-FFF2-40B4-BE49-F238E27FC236}">
-                <a16:creationId xmlns:a16="http://schemas.microsoft.com/office/drawing/2014/main" id="{FEFBC681-9C25-458A-A5E0-B59795917D4D}"/>
+                <a16:creationId xmlns:a16="http://schemas.microsoft.com/office/drawing/2014/main" id="{03EF5085-B7B1-4A65-9C49-C81CEA06A84B}"/>
               </a:ext>
             </a:extLst>
           </p:cNvPr>
@@ -3461,7 +3461,7 @@
           <p:cNvPr id="9" name="">
             <a:extLst xmlns:a="http://schemas.openxmlformats.org/drawingml/2006/main">
               <a:ext uri="{FF2B5EF4-FFF2-40B4-BE49-F238E27FC236}">
-                <a16:creationId xmlns:a16="http://schemas.microsoft.com/office/drawing/2014/main" id="{C54E75D7-9B2F-4EAE-86E7-48718EE31628}"/>
+                <a16:creationId xmlns:a16="http://schemas.microsoft.com/office/drawing/2014/main" id="{1070EF5B-A8B3-4D0C-AE2D-68CA7FA90EA7}"/>
               </a:ext>
             </a:extLst>
           </p:cNvPr>
@@ -3516,7 +3516,7 @@
     </p:spTree>
     <p:extLst>
       <p:ext uri="{BB962C8B-B14F-4D97-AF65-F5344CB8AC3E}">
-        <p14:creationId xmlns:p14="http://schemas.microsoft.com/office/powerpoint/2010/main" val="671831814"/>
+        <p14:creationId xmlns:p14="http://schemas.microsoft.com/office/powerpoint/2010/main" val="1230699116"/>
       </p:ext>
     </p:extLst>
   </p:cSld>
@@ -3547,7 +3547,7 @@
           <p:cNvPr id="7" name="">
             <a:extLst xmlns:a="http://schemas.openxmlformats.org/drawingml/2006/main">
               <a:ext uri="{FF2B5EF4-FFF2-40B4-BE49-F238E27FC236}">
-                <a16:creationId xmlns:a16="http://schemas.microsoft.com/office/drawing/2014/main" id="{5214154B-4AA9-43FE-95A4-927F27F6B6F2}"/>
+                <a16:creationId xmlns:a16="http://schemas.microsoft.com/office/drawing/2014/main" id="{33792505-9221-4D98-834C-4F0D24644D0A}"/>
               </a:ext>
             </a:extLst>
           </p:cNvPr>
@@ -3604,7 +3604,7 @@
           <p:cNvPr id="2" name="">
             <a:extLst xmlns:a="http://schemas.openxmlformats.org/drawingml/2006/main">
               <a:ext uri="{FF2B5EF4-FFF2-40B4-BE49-F238E27FC236}">
-                <a16:creationId xmlns:a16="http://schemas.microsoft.com/office/drawing/2014/main" id="{E81EB9C9-B6F1-47D1-92BD-97B7D3229D94}"/>
+                <a16:creationId xmlns:a16="http://schemas.microsoft.com/office/drawing/2014/main" id="{1D4D5429-F42B-430B-8EAA-D226CA30AA7A}"/>
               </a:ext>
             </a:extLst>
           </p:cNvPr>
@@ -3661,7 +3661,7 @@
           <p:cNvPr id="3" name="">
             <a:extLst xmlns:a="http://schemas.openxmlformats.org/drawingml/2006/main">
               <a:ext uri="{FF2B5EF4-FFF2-40B4-BE49-F238E27FC236}">
-                <a16:creationId xmlns:a16="http://schemas.microsoft.com/office/drawing/2014/main" id="{45574CBB-D876-4DB9-B0D8-533EDFE5AFBD}"/>
+                <a16:creationId xmlns:a16="http://schemas.microsoft.com/office/drawing/2014/main" id="{6E5471A5-CF6D-4F01-B418-13D1DC39EBF4}"/>
               </a:ext>
             </a:extLst>
           </p:cNvPr>
@@ -3718,7 +3718,7 @@
           <p:cNvPr id="4" name="">
             <a:extLst xmlns:a="http://schemas.openxmlformats.org/drawingml/2006/main">
               <a:ext uri="{FF2B5EF4-FFF2-40B4-BE49-F238E27FC236}">
-                <a16:creationId xmlns:a16="http://schemas.microsoft.com/office/drawing/2014/main" id="{FAD1280A-DB30-4FDD-B976-72A36F776441}"/>
+                <a16:creationId xmlns:a16="http://schemas.microsoft.com/office/drawing/2014/main" id="{1FB2F17F-0E4B-4192-8E97-A77051829731}"/>
               </a:ext>
             </a:extLst>
           </p:cNvPr>
@@ -3775,7 +3775,7 @@
           <p:cNvPr id="5" name="">
             <a:extLst xmlns:a="http://schemas.openxmlformats.org/drawingml/2006/main">
               <a:ext uri="{FF2B5EF4-FFF2-40B4-BE49-F238E27FC236}">
-                <a16:creationId xmlns:a16="http://schemas.microsoft.com/office/drawing/2014/main" id="{D88ACF2E-30ED-46A4-AE0C-C291869D41F6}"/>
+                <a16:creationId xmlns:a16="http://schemas.microsoft.com/office/drawing/2014/main" id="{2B4888CF-7E75-4AD6-B590-16EC1C0E43CC}"/>
               </a:ext>
             </a:extLst>
           </p:cNvPr>
@@ -3832,7 +3832,7 @@
           <p:cNvPr id="6" name="">
             <a:extLst xmlns:a="http://schemas.openxmlformats.org/drawingml/2006/main">
               <a:ext uri="{FF2B5EF4-FFF2-40B4-BE49-F238E27FC236}">
-                <a16:creationId xmlns:a16="http://schemas.microsoft.com/office/drawing/2014/main" id="{10616B5C-CD4D-4535-A270-C7C5127D57F9}"/>
+                <a16:creationId xmlns:a16="http://schemas.microsoft.com/office/drawing/2014/main" id="{7C36992E-1C28-4E6D-BD7F-E8A1926B437F}"/>
               </a:ext>
             </a:extLst>
           </p:cNvPr>
@@ -3879,7 +3879,7 @@
                 <a:ea typeface="Arial"/>
                 <a:cs typeface="Arial"/>
               </a:rPr>
-              <a:t>The lab uses a separate judge token shared privately. The event workflow runs in Slack.</a:t>
+              <a:t>New sandbox runs require a separate judge token; private delivery to judges is pending. The event workflow runs in Slack.</a:t>
             </a:r>
           </a:p>
         </p:txBody>
@@ -3887,7 +3887,7 @@
     </p:spTree>
     <p:extLst>
       <p:ext uri="{BB962C8B-B14F-4D97-AF65-F5344CB8AC3E}">
-        <p14:creationId xmlns:p14="http://schemas.microsoft.com/office/powerpoint/2010/main" val="1049385193"/>
+        <p14:creationId xmlns:p14="http://schemas.microsoft.com/office/powerpoint/2010/main" val="58816010"/>
       </p:ext>
     </p:extLst>
   </p:cSld>

</xml_diff>